<commit_message>
Lab highlights: 7 slides
</commit_message>
<xml_diff>
--- a/docs/files/Lab_Highlights.pptx
+++ b/docs/files/Lab_Highlights.pptx
@@ -11,6 +11,7 @@
     <p:sldId id="259" r:id="rId10"/>
     <p:sldId id="260" r:id="rId11"/>
     <p:sldId id="261" r:id="rId12"/>
+    <p:sldId id="262" r:id="rId13"/>
   </p:sldIdLst>
   <p:sldSz cx="12191695" cy="6858000" type="screen4x3"/>
   <p:notesSz cx="6858000" cy="9144000"/>
@@ -3210,7 +3211,7 @@
                 </a:solidFill>
                 <a:latin typeface="Segoe UI Semibold"/>
               </a:rPr>
-              <a:t>Four labs, one slide each</a:t>
+              <a:t>Four labs at a glance</a:t>
             </a:r>
           </a:p>
         </p:txBody>
@@ -4273,7 +4274,7 @@
                 </a:solidFill>
                 <a:latin typeface="Segoe UI"/>
               </a:rPr>
-              <a:t>2 / 6</a:t>
+              <a:t>2 / 7</a:t>
             </a:r>
           </a:p>
         </p:txBody>
@@ -5136,7 +5137,7 @@
                 </a:solidFill>
                 <a:latin typeface="Segoe UI Semibold"/>
               </a:rPr>
-              <a:t>ECE 203 · ELECTRICAL CIRCUITS II · LAB 6</a:t>
+              <a:t>ECE 302 · LAB 2 · HOW IT WAS BUILT</a:t>
             </a:r>
           </a:p>
         </p:txBody>
@@ -5175,7 +5176,7 @@
                 </a:solidFill>
                 <a:latin typeface="Segoe UI Semibold"/>
               </a:rPr>
-              <a:t>Four filters, measured against the math</a:t>
+              <a:t>From schematic to scope</a:t>
             </a:r>
           </a:p>
         </p:txBody>
@@ -5214,7 +5215,7 @@
                 </a:solidFill>
                 <a:latin typeface="Segoe UI"/>
               </a:rPr>
-              <a:t>Individual results sheet (Mar 2026). Measured points from my tables; theory uses the nominal 470 Ω, 100 nF, 10 mH.</a:t>
+              <a:t>Group lab with Rohan Singh. Figures from our submitted report: LTspice schematic and transient run, the breadboard build, the bench scope.</a:t>
             </a:r>
           </a:p>
         </p:txBody>
@@ -5253,248 +5254,60 @@
                 </a:solidFill>
                 <a:latin typeface="Segoe UI"/>
               </a:rPr>
-              <a:t>3 / 6</a:t>
-            </a:r>
-          </a:p>
-        </p:txBody>
-      </p:sp>
-      <p:sp>
-        <p:nvSpPr>
-          <p:cNvPr id="7" name="TextBox 6"/>
-          <p:cNvSpPr txBox="1"/>
-          <p:nvPr/>
-        </p:nvSpPr>
-        <p:spPr>
-          <a:xfrm>
-            <a:off x="640080" y="1463040"/>
-            <a:ext cx="3566160" cy="274320"/>
-          </a:xfrm>
-          <a:prstGeom prst="rect">
-            <a:avLst/>
-          </a:prstGeom>
-          <a:noFill/>
-        </p:spPr>
-        <p:txBody>
-          <a:bodyPr wrap="square" anchor="t" lIns="0" rIns="0" tIns="0" bIns="0">
-            <a:spAutoFit/>
-          </a:bodyPr>
-          <a:lstStyle/>
-          <a:p>
-            <a:pPr algn="l">
-              <a:lnSpc>
-                <a:spcPct val="110000"/>
-              </a:lnSpc>
-            </a:pPr>
-            <a:r>
-              <a:rPr sz="1050" b="0">
-                <a:solidFill>
-                  <a:srgbClr val="1F3A5F"/>
-                </a:solidFill>
-                <a:latin typeface="Segoe UI Semibold"/>
-              </a:rPr>
-              <a:t>THE QUESTION</a:t>
-            </a:r>
-          </a:p>
-        </p:txBody>
-      </p:sp>
-      <p:sp>
-        <p:nvSpPr>
-          <p:cNvPr id="8" name="TextBox 7"/>
-          <p:cNvSpPr txBox="1"/>
-          <p:nvPr/>
-        </p:nvSpPr>
-        <p:spPr>
-          <a:xfrm>
-            <a:off x="640080" y="1709928"/>
-            <a:ext cx="3566160" cy="1280160"/>
-          </a:xfrm>
-          <a:prstGeom prst="rect">
-            <a:avLst/>
-          </a:prstGeom>
-          <a:noFill/>
-        </p:spPr>
-        <p:txBody>
-          <a:bodyPr wrap="square" anchor="t" lIns="0" rIns="0" tIns="0" bIns="0">
-            <a:spAutoFit/>
-          </a:bodyPr>
-          <a:lstStyle/>
-          <a:p>
-            <a:pPr algn="l">
-              <a:lnSpc>
-                <a:spcPct val="112000"/>
-              </a:lnSpc>
-            </a:pPr>
-            <a:r>
-              <a:rPr sz="1350" b="0">
-                <a:solidFill>
-                  <a:srgbClr val="1E2430"/>
-                </a:solidFill>
-                <a:latin typeface="Segoe UI"/>
-              </a:rPr>
-              <a:t>Do real RC, RL and RLC filters cut off where 1/(2πRC), R/(2πL) and 1/(2π√LC) say they should?</a:t>
-            </a:r>
-          </a:p>
-        </p:txBody>
-      </p:sp>
-      <p:sp>
-        <p:nvSpPr>
-          <p:cNvPr id="9" name="TextBox 8"/>
-          <p:cNvSpPr txBox="1"/>
-          <p:nvPr/>
-        </p:nvSpPr>
-        <p:spPr>
-          <a:xfrm>
-            <a:off x="640080" y="2715768"/>
-            <a:ext cx="3566160" cy="274320"/>
-          </a:xfrm>
-          <a:prstGeom prst="rect">
-            <a:avLst/>
-          </a:prstGeom>
-          <a:noFill/>
-        </p:spPr>
-        <p:txBody>
-          <a:bodyPr wrap="square" anchor="t" lIns="0" rIns="0" tIns="0" bIns="0">
-            <a:spAutoFit/>
-          </a:bodyPr>
-          <a:lstStyle/>
-          <a:p>
-            <a:pPr algn="l">
-              <a:lnSpc>
-                <a:spcPct val="110000"/>
-              </a:lnSpc>
-            </a:pPr>
-            <a:r>
-              <a:rPr sz="1050" b="0">
-                <a:solidFill>
-                  <a:srgbClr val="1F3A5F"/>
-                </a:solidFill>
-                <a:latin typeface="Segoe UI Semibold"/>
-              </a:rPr>
-              <a:t>WHAT I DID</a:t>
-            </a:r>
-          </a:p>
-        </p:txBody>
-      </p:sp>
-      <p:sp>
-        <p:nvSpPr>
-          <p:cNvPr id="10" name="TextBox 9"/>
-          <p:cNvSpPr txBox="1"/>
-          <p:nvPr/>
-        </p:nvSpPr>
-        <p:spPr>
-          <a:xfrm>
-            <a:off x="640080" y="2962656"/>
-            <a:ext cx="3566160" cy="1280160"/>
-          </a:xfrm>
-          <a:prstGeom prst="rect">
-            <a:avLst/>
-          </a:prstGeom>
-          <a:noFill/>
-        </p:spPr>
-        <p:txBody>
-          <a:bodyPr wrap="square" anchor="t" lIns="0" rIns="0" tIns="0" bIns="0">
-            <a:spAutoFit/>
-          </a:bodyPr>
-          <a:lstStyle/>
-          <a:p>
-            <a:pPr algn="l">
-              <a:lnSpc>
-                <a:spcPct val="112000"/>
-              </a:lnSpc>
-            </a:pPr>
-            <a:r>
-              <a:rPr sz="1350" b="0">
-                <a:solidFill>
-                  <a:srgbClr val="1E2430"/>
-                </a:solidFill>
-                <a:latin typeface="Segoe UI"/>
-              </a:rPr>
-              <a:t>Swept each filter from 100 Hz to 100 kHz on the function generator and scope, and found each −3 dB point.</a:t>
-            </a:r>
-          </a:p>
-        </p:txBody>
-      </p:sp>
-      <p:sp>
-        <p:nvSpPr>
-          <p:cNvPr id="11" name="TextBox 10"/>
-          <p:cNvSpPr txBox="1"/>
-          <p:nvPr/>
-        </p:nvSpPr>
-        <p:spPr>
-          <a:xfrm>
-            <a:off x="640080" y="3968496"/>
-            <a:ext cx="3566160" cy="274320"/>
-          </a:xfrm>
-          <a:prstGeom prst="rect">
-            <a:avLst/>
-          </a:prstGeom>
-          <a:noFill/>
-        </p:spPr>
-        <p:txBody>
-          <a:bodyPr wrap="square" anchor="t" lIns="0" rIns="0" tIns="0" bIns="0">
-            <a:spAutoFit/>
-          </a:bodyPr>
-          <a:lstStyle/>
-          <a:p>
-            <a:pPr algn="l">
-              <a:lnSpc>
-                <a:spcPct val="110000"/>
-              </a:lnSpc>
-            </a:pPr>
-            <a:r>
-              <a:rPr sz="1050" b="0">
-                <a:solidFill>
-                  <a:srgbClr val="2A9D8F"/>
-                </a:solidFill>
-                <a:latin typeface="Segoe UI Semibold"/>
-              </a:rPr>
-              <a:t>CONCLUSION</a:t>
-            </a:r>
-          </a:p>
-        </p:txBody>
-      </p:sp>
-      <p:sp>
-        <p:nvSpPr>
-          <p:cNvPr id="12" name="TextBox 11"/>
-          <p:cNvSpPr txBox="1"/>
-          <p:nvPr/>
-        </p:nvSpPr>
-        <p:spPr>
-          <a:xfrm>
-            <a:off x="640080" y="4215384"/>
-            <a:ext cx="3566160" cy="1280160"/>
-          </a:xfrm>
-          <a:prstGeom prst="rect">
-            <a:avLst/>
-          </a:prstGeom>
-          <a:noFill/>
-        </p:spPr>
-        <p:txBody>
-          <a:bodyPr wrap="square" anchor="t" lIns="0" rIns="0" tIns="0" bIns="0">
-            <a:spAutoFit/>
-          </a:bodyPr>
-          <a:lstStyle/>
-          <a:p>
-            <a:pPr algn="l">
-              <a:lnSpc>
-                <a:spcPct val="112000"/>
-              </a:lnSpc>
-            </a:pPr>
-            <a:r>
-              <a:rPr sz="1350" b="0">
-                <a:solidFill>
-                  <a:srgbClr val="1E2430"/>
-                </a:solidFill>
-                <a:latin typeface="Segoe UI"/>
-              </a:rPr>
-              <a:t>Every corner landed within 5.4 % of theory. Both RC cut-offs ran high by the same 5 %, consistent with the capacitor being about 95 nF (within its tolerance).</a:t>
-            </a:r>
+              <a:t>3 / 7</a:t>
+            </a:r>
+          </a:p>
+        </p:txBody>
+      </p:sp>
+      <p:sp>
+        <p:nvSpPr>
+          <p:cNvPr id="7" name="Rounded Rectangle 6"/>
+          <p:cNvSpPr/>
+          <p:nvPr/>
+        </p:nvSpPr>
+        <p:spPr>
+          <a:xfrm>
+            <a:off x="640080" y="1481328"/>
+            <a:ext cx="2615184" cy="3246120"/>
+          </a:xfrm>
+          <a:prstGeom prst="roundRect">
+            <a:avLst>
+              <a:gd name="adj" fmla="val 4000"/>
+            </a:avLst>
+          </a:prstGeom>
+          <a:solidFill>
+            <a:srgbClr val="EEF2F6"/>
+          </a:solidFill>
+          <a:ln>
+            <a:noFill/>
+          </a:ln>
+          <a:effectLst/>
+        </p:spPr>
+        <p:style>
+          <a:lnRef idx="1">
+            <a:schemeClr val="accent1"/>
+          </a:lnRef>
+          <a:fillRef idx="3">
+            <a:schemeClr val="accent1"/>
+          </a:fillRef>
+          <a:effectRef idx="2">
+            <a:schemeClr val="accent1"/>
+          </a:effectRef>
+          <a:fontRef idx="minor">
+            <a:schemeClr val="lt1"/>
+          </a:fontRef>
+        </p:style>
+        <p:txBody>
+          <a:bodyPr rtlCol="0" anchor="ctr"/>
+          <a:lstStyle/>
+          <a:p>
+            <a:pPr algn="ctr"/>
           </a:p>
         </p:txBody>
       </p:sp>
       <p:pic>
         <p:nvPicPr>
-          <p:cNvPr id="13" name="Picture 12" descr="lab_filters.png"/>
+          <p:cNvPr id="8" name="Picture 7" descr="v2_p4_1.png"/>
           <p:cNvPicPr>
             <a:picLocks noChangeAspect="1"/>
           </p:cNvPicPr>
@@ -5508,8 +5321,8 @@
         </p:blipFill>
         <p:spPr>
           <a:xfrm>
-            <a:off x="4526280" y="1325880"/>
-            <a:ext cx="5820966" cy="3611880"/>
+            <a:off x="749807" y="2056374"/>
+            <a:ext cx="2395728" cy="2096028"/>
           </a:xfrm>
           <a:prstGeom prst="rect">
             <a:avLst/>
@@ -5518,18 +5331,135 @@
       </p:pic>
       <p:sp>
         <p:nvSpPr>
-          <p:cNvPr id="14" name="Rounded Rectangle 13"/>
+          <p:cNvPr id="9" name="TextBox 8"/>
+          <p:cNvSpPr txBox="1"/>
+          <p:nvPr/>
+        </p:nvSpPr>
+        <p:spPr>
+          <a:xfrm>
+            <a:off x="640080" y="4892040"/>
+            <a:ext cx="2615184" cy="320040"/>
+          </a:xfrm>
+          <a:prstGeom prst="rect">
+            <a:avLst/>
+          </a:prstGeom>
+          <a:noFill/>
+        </p:spPr>
+        <p:txBody>
+          <a:bodyPr wrap="square" anchor="t" lIns="0" rIns="0" tIns="0" bIns="0">
+            <a:spAutoFit/>
+          </a:bodyPr>
+          <a:lstStyle/>
+          <a:p>
+            <a:pPr algn="l">
+              <a:lnSpc>
+                <a:spcPct val="110000"/>
+              </a:lnSpc>
+            </a:pPr>
+            <a:r>
+              <a:rPr sz="1400" b="0">
+                <a:solidFill>
+                  <a:srgbClr val="1F3A5F"/>
+                </a:solidFill>
+                <a:latin typeface="Segoe UI Semibold"/>
+              </a:rPr>
+              <a:t>1  ·  Design in LTspice</a:t>
+            </a:r>
+          </a:p>
+        </p:txBody>
+      </p:sp>
+      <p:sp>
+        <p:nvSpPr>
+          <p:cNvPr id="10" name="TextBox 9"/>
+          <p:cNvSpPr txBox="1"/>
+          <p:nvPr/>
+        </p:nvSpPr>
+        <p:spPr>
+          <a:xfrm>
+            <a:off x="640080" y="5230368"/>
+            <a:ext cx="2615184" cy="1005840"/>
+          </a:xfrm>
+          <a:prstGeom prst="rect">
+            <a:avLst/>
+          </a:prstGeom>
+          <a:noFill/>
+        </p:spPr>
+        <p:txBody>
+          <a:bodyPr wrap="square" anchor="t" lIns="0" rIns="0" tIns="0" bIns="0">
+            <a:spAutoFit/>
+          </a:bodyPr>
+          <a:lstStyle/>
+          <a:p>
+            <a:pPr algn="l">
+              <a:lnSpc>
+                <a:spcPct val="108000"/>
+              </a:lnSpc>
+            </a:pPr>
+            <a:r>
+              <a:rPr sz="1150" b="0">
+                <a:solidFill>
+                  <a:srgbClr val="6B7586"/>
+                </a:solidFill>
+                <a:latin typeface="Segoe UI"/>
+              </a:rPr>
+              <a:t>Transformer, full-wave centre-tapped rectifiers, 78L10 on the + rail, 1N4740 Zener shunt on the − rail.</a:t>
+            </a:r>
+          </a:p>
+        </p:txBody>
+      </p:sp>
+      <p:sp>
+        <p:nvSpPr>
+          <p:cNvPr id="11" name="TextBox 10"/>
+          <p:cNvSpPr txBox="1"/>
+          <p:nvPr/>
+        </p:nvSpPr>
+        <p:spPr>
+          <a:xfrm>
+            <a:off x="3273551" y="2921508"/>
+            <a:ext cx="182880" cy="365760"/>
+          </a:xfrm>
+          <a:prstGeom prst="rect">
+            <a:avLst/>
+          </a:prstGeom>
+          <a:noFill/>
+        </p:spPr>
+        <p:txBody>
+          <a:bodyPr wrap="square" anchor="t" lIns="0" rIns="0" tIns="0" bIns="0">
+            <a:spAutoFit/>
+          </a:bodyPr>
+          <a:lstStyle/>
+          <a:p>
+            <a:pPr algn="l">
+              <a:lnSpc>
+                <a:spcPct val="110000"/>
+              </a:lnSpc>
+            </a:pPr>
+            <a:r>
+              <a:rPr sz="2200" b="0">
+                <a:solidFill>
+                  <a:srgbClr val="2A9D8F"/>
+                </a:solidFill>
+                <a:latin typeface="Segoe UI Semibold"/>
+              </a:rPr>
+              <a:t>›</a:t>
+            </a:r>
+          </a:p>
+        </p:txBody>
+      </p:sp>
+      <p:sp>
+        <p:nvSpPr>
+          <p:cNvPr id="12" name="Rounded Rectangle 11"/>
           <p:cNvSpPr/>
           <p:nvPr/>
         </p:nvSpPr>
         <p:spPr>
           <a:xfrm>
-            <a:off x="4526280" y="5074920"/>
-            <a:ext cx="2377440" cy="1188720"/>
+            <a:off x="3438144" y="1481328"/>
+            <a:ext cx="2615184" cy="3246120"/>
           </a:xfrm>
           <a:prstGeom prst="roundRect">
             <a:avLst>
-              <a:gd name="adj" fmla="val 8000"/>
+              <a:gd name="adj" fmla="val 4000"/>
             </a:avLst>
           </a:prstGeom>
           <a:solidFill>
@@ -5562,142 +5492,161 @@
           </a:p>
         </p:txBody>
       </p:sp>
-      <p:sp>
-        <p:nvSpPr>
-          <p:cNvPr id="15" name="Rectangle 14"/>
+      <p:pic>
+        <p:nvPicPr>
+          <p:cNvPr id="13" name="Picture 12" descr="v2_p6_2.png"/>
+          <p:cNvPicPr>
+            <a:picLocks noChangeAspect="1"/>
+          </p:cNvPicPr>
+          <p:nvPr/>
+        </p:nvPicPr>
+        <p:blipFill>
+          <a:blip r:embed="rId3"/>
+          <a:stretch>
+            <a:fillRect/>
+          </a:stretch>
+        </p:blipFill>
+        <p:spPr>
+          <a:xfrm>
+            <a:off x="3547872" y="2479135"/>
+            <a:ext cx="2395728" cy="1250505"/>
+          </a:xfrm>
+          <a:prstGeom prst="rect">
+            <a:avLst/>
+          </a:prstGeom>
+        </p:spPr>
+      </p:pic>
+      <p:sp>
+        <p:nvSpPr>
+          <p:cNvPr id="14" name="TextBox 13"/>
+          <p:cNvSpPr txBox="1"/>
+          <p:nvPr/>
+        </p:nvSpPr>
+        <p:spPr>
+          <a:xfrm>
+            <a:off x="3438144" y="4892040"/>
+            <a:ext cx="2615184" cy="320040"/>
+          </a:xfrm>
+          <a:prstGeom prst="rect">
+            <a:avLst/>
+          </a:prstGeom>
+          <a:noFill/>
+        </p:spPr>
+        <p:txBody>
+          <a:bodyPr wrap="square" anchor="t" lIns="0" rIns="0" tIns="0" bIns="0">
+            <a:spAutoFit/>
+          </a:bodyPr>
+          <a:lstStyle/>
+          <a:p>
+            <a:pPr algn="l">
+              <a:lnSpc>
+                <a:spcPct val="110000"/>
+              </a:lnSpc>
+            </a:pPr>
+            <a:r>
+              <a:rPr sz="1400" b="0">
+                <a:solidFill>
+                  <a:srgbClr val="1F3A5F"/>
+                </a:solidFill>
+                <a:latin typeface="Segoe UI Semibold"/>
+              </a:rPr>
+              <a:t>2  ·  Simulate</a:t>
+            </a:r>
+          </a:p>
+        </p:txBody>
+      </p:sp>
+      <p:sp>
+        <p:nvSpPr>
+          <p:cNvPr id="15" name="TextBox 14"/>
+          <p:cNvSpPr txBox="1"/>
+          <p:nvPr/>
+        </p:nvSpPr>
+        <p:spPr>
+          <a:xfrm>
+            <a:off x="3438144" y="5230368"/>
+            <a:ext cx="2615184" cy="1005840"/>
+          </a:xfrm>
+          <a:prstGeom prst="rect">
+            <a:avLst/>
+          </a:prstGeom>
+          <a:noFill/>
+        </p:spPr>
+        <p:txBody>
+          <a:bodyPr wrap="square" anchor="t" lIns="0" rIns="0" tIns="0" bIns="0">
+            <a:spAutoFit/>
+          </a:bodyPr>
+          <a:lstStyle/>
+          <a:p>
+            <a:pPr algn="l">
+              <a:lnSpc>
+                <a:spcPct val="108000"/>
+              </a:lnSpc>
+            </a:pPr>
+            <a:r>
+              <a:rPr sz="1150" b="0">
+                <a:solidFill>
+                  <a:srgbClr val="6B7586"/>
+                </a:solidFill>
+                <a:latin typeface="Segoe UI"/>
+              </a:rPr>
+              <a:t>Transient run: both rails settle to ±10 V within about 3 ms. Load stepped with .step to get full-load and no-load.</a:t>
+            </a:r>
+          </a:p>
+        </p:txBody>
+      </p:sp>
+      <p:sp>
+        <p:nvSpPr>
+          <p:cNvPr id="16" name="TextBox 15"/>
+          <p:cNvSpPr txBox="1"/>
+          <p:nvPr/>
+        </p:nvSpPr>
+        <p:spPr>
+          <a:xfrm>
+            <a:off x="6071615" y="2921508"/>
+            <a:ext cx="182880" cy="365760"/>
+          </a:xfrm>
+          <a:prstGeom prst="rect">
+            <a:avLst/>
+          </a:prstGeom>
+          <a:noFill/>
+        </p:spPr>
+        <p:txBody>
+          <a:bodyPr wrap="square" anchor="t" lIns="0" rIns="0" tIns="0" bIns="0">
+            <a:spAutoFit/>
+          </a:bodyPr>
+          <a:lstStyle/>
+          <a:p>
+            <a:pPr algn="l">
+              <a:lnSpc>
+                <a:spcPct val="110000"/>
+              </a:lnSpc>
+            </a:pPr>
+            <a:r>
+              <a:rPr sz="2200" b="0">
+                <a:solidFill>
+                  <a:srgbClr val="2A9D8F"/>
+                </a:solidFill>
+                <a:latin typeface="Segoe UI Semibold"/>
+              </a:rPr>
+              <a:t>›</a:t>
+            </a:r>
+          </a:p>
+        </p:txBody>
+      </p:sp>
+      <p:sp>
+        <p:nvSpPr>
+          <p:cNvPr id="17" name="Rounded Rectangle 16"/>
           <p:cNvSpPr/>
           <p:nvPr/>
         </p:nvSpPr>
         <p:spPr>
           <a:xfrm>
-            <a:off x="4526280" y="5074920"/>
-            <a:ext cx="64008" cy="1188720"/>
-          </a:xfrm>
-          <a:prstGeom prst="rect">
-            <a:avLst/>
-          </a:prstGeom>
-          <a:solidFill>
-            <a:srgbClr val="1F3A5F"/>
-          </a:solidFill>
-          <a:ln>
-            <a:noFill/>
-          </a:ln>
-          <a:effectLst/>
-        </p:spPr>
-        <p:style>
-          <a:lnRef idx="1">
-            <a:schemeClr val="accent1"/>
-          </a:lnRef>
-          <a:fillRef idx="3">
-            <a:schemeClr val="accent1"/>
-          </a:fillRef>
-          <a:effectRef idx="2">
-            <a:schemeClr val="accent1"/>
-          </a:effectRef>
-          <a:fontRef idx="minor">
-            <a:schemeClr val="lt1"/>
-          </a:fontRef>
-        </p:style>
-        <p:txBody>
-          <a:bodyPr rtlCol="0" anchor="ctr"/>
-          <a:lstStyle/>
-          <a:p>
-            <a:pPr algn="ctr"/>
-          </a:p>
-        </p:txBody>
-      </p:sp>
-      <p:sp>
-        <p:nvSpPr>
-          <p:cNvPr id="16" name="TextBox 15"/>
-          <p:cNvSpPr txBox="1"/>
-          <p:nvPr/>
-        </p:nvSpPr>
-        <p:spPr>
-          <a:xfrm>
-            <a:off x="4754880" y="5221224"/>
-            <a:ext cx="2057400" cy="457200"/>
-          </a:xfrm>
-          <a:prstGeom prst="rect">
-            <a:avLst/>
-          </a:prstGeom>
-          <a:noFill/>
-        </p:spPr>
-        <p:txBody>
-          <a:bodyPr wrap="square" anchor="t" lIns="0" rIns="0" tIns="0" bIns="0">
-            <a:spAutoFit/>
-          </a:bodyPr>
-          <a:lstStyle/>
-          <a:p>
-            <a:pPr algn="l">
-              <a:lnSpc>
-                <a:spcPct val="110000"/>
-              </a:lnSpc>
-            </a:pPr>
-            <a:r>
-              <a:rPr sz="2200" b="0">
-                <a:solidFill>
-                  <a:srgbClr val="1F3A5F"/>
-                </a:solidFill>
-                <a:latin typeface="Segoe UI Semibold"/>
-              </a:rPr>
-              <a:t>−0.4 %</a:t>
-            </a:r>
-          </a:p>
-        </p:txBody>
-      </p:sp>
-      <p:sp>
-        <p:nvSpPr>
-          <p:cNvPr id="17" name="TextBox 16"/>
-          <p:cNvSpPr txBox="1"/>
-          <p:nvPr/>
-        </p:nvSpPr>
-        <p:spPr>
-          <a:xfrm>
-            <a:off x="4754880" y="5678424"/>
-            <a:ext cx="2057400" cy="548640"/>
-          </a:xfrm>
-          <a:prstGeom prst="rect">
-            <a:avLst/>
-          </a:prstGeom>
-          <a:noFill/>
-        </p:spPr>
-        <p:txBody>
-          <a:bodyPr wrap="square" anchor="t" lIns="0" rIns="0" tIns="0" bIns="0">
-            <a:spAutoFit/>
-          </a:bodyPr>
-          <a:lstStyle/>
-          <a:p>
-            <a:pPr algn="l">
-              <a:lnSpc>
-                <a:spcPct val="105000"/>
-              </a:lnSpc>
-            </a:pPr>
-            <a:r>
-              <a:rPr sz="1100" b="0">
-                <a:solidFill>
-                  <a:srgbClr val="6B7586"/>
-                </a:solidFill>
-                <a:latin typeface="Segoe UI"/>
-              </a:rPr>
-              <a:t>RLC centre frequency vs theory (5,013 vs 5,033 Hz)</a:t>
-            </a:r>
-          </a:p>
-        </p:txBody>
-      </p:sp>
-      <p:sp>
-        <p:nvSpPr>
-          <p:cNvPr id="18" name="Rounded Rectangle 17"/>
-          <p:cNvSpPr/>
-          <p:nvPr/>
-        </p:nvSpPr>
-        <p:spPr>
-          <a:xfrm>
-            <a:off x="7022592" y="5074920"/>
-            <a:ext cx="2377440" cy="1188720"/>
+            <a:off x="6236208" y="1481328"/>
+            <a:ext cx="2615184" cy="3246120"/>
           </a:xfrm>
           <a:prstGeom prst="roundRect">
             <a:avLst>
-              <a:gd name="adj" fmla="val 8000"/>
+              <a:gd name="adj" fmla="val 4000"/>
             </a:avLst>
           </a:prstGeom>
           <a:solidFill>
@@ -5730,47 +5679,66 @@
           </a:p>
         </p:txBody>
       </p:sp>
-      <p:sp>
-        <p:nvSpPr>
-          <p:cNvPr id="19" name="Rectangle 18"/>
-          <p:cNvSpPr/>
-          <p:nvPr/>
-        </p:nvSpPr>
-        <p:spPr>
-          <a:xfrm>
-            <a:off x="7022592" y="5074920"/>
-            <a:ext cx="64008" cy="1188720"/>
-          </a:xfrm>
-          <a:prstGeom prst="rect">
-            <a:avLst/>
-          </a:prstGeom>
-          <a:solidFill>
-            <a:srgbClr val="E9A23B"/>
-          </a:solidFill>
-          <a:ln>
-            <a:noFill/>
-          </a:ln>
-          <a:effectLst/>
-        </p:spPr>
-        <p:style>
-          <a:lnRef idx="1">
-            <a:schemeClr val="accent1"/>
-          </a:lnRef>
-          <a:fillRef idx="3">
-            <a:schemeClr val="accent1"/>
-          </a:fillRef>
-          <a:effectRef idx="2">
-            <a:schemeClr val="accent1"/>
-          </a:effectRef>
-          <a:fontRef idx="minor">
-            <a:schemeClr val="lt1"/>
-          </a:fontRef>
-        </p:style>
-        <p:txBody>
-          <a:bodyPr rtlCol="0" anchor="ctr"/>
-          <a:lstStyle/>
-          <a:p>
-            <a:pPr algn="ctr"/>
+      <p:pic>
+        <p:nvPicPr>
+          <p:cNvPr id="18" name="Picture 17" descr="v2_p3_0.png"/>
+          <p:cNvPicPr>
+            <a:picLocks noChangeAspect="1"/>
+          </p:cNvPicPr>
+          <p:nvPr/>
+        </p:nvPicPr>
+        <p:blipFill>
+          <a:blip r:embed="rId4"/>
+          <a:stretch>
+            <a:fillRect/>
+          </a:stretch>
+        </p:blipFill>
+        <p:spPr>
+          <a:xfrm>
+            <a:off x="6345936" y="1713441"/>
+            <a:ext cx="2395728" cy="2781894"/>
+          </a:xfrm>
+          <a:prstGeom prst="rect">
+            <a:avLst/>
+          </a:prstGeom>
+        </p:spPr>
+      </p:pic>
+      <p:sp>
+        <p:nvSpPr>
+          <p:cNvPr id="19" name="TextBox 18"/>
+          <p:cNvSpPr txBox="1"/>
+          <p:nvPr/>
+        </p:nvSpPr>
+        <p:spPr>
+          <a:xfrm>
+            <a:off x="6236208" y="4892040"/>
+            <a:ext cx="2615184" cy="320040"/>
+          </a:xfrm>
+          <a:prstGeom prst="rect">
+            <a:avLst/>
+          </a:prstGeom>
+          <a:noFill/>
+        </p:spPr>
+        <p:txBody>
+          <a:bodyPr wrap="square" anchor="t" lIns="0" rIns="0" tIns="0" bIns="0">
+            <a:spAutoFit/>
+          </a:bodyPr>
+          <a:lstStyle/>
+          <a:p>
+            <a:pPr algn="l">
+              <a:lnSpc>
+                <a:spcPct val="110000"/>
+              </a:lnSpc>
+            </a:pPr>
+            <a:r>
+              <a:rPr sz="1400" b="0">
+                <a:solidFill>
+                  <a:srgbClr val="1F3A5F"/>
+                </a:solidFill>
+                <a:latin typeface="Segoe UI Semibold"/>
+              </a:rPr>
+              <a:t>3  ·  Build</a:t>
+            </a:r>
           </a:p>
         </p:txBody>
       </p:sp>
@@ -5782,8 +5750,47 @@
         </p:nvSpPr>
         <p:spPr>
           <a:xfrm>
-            <a:off x="7251192" y="5221224"/>
-            <a:ext cx="2057400" cy="457200"/>
+            <a:off x="6236208" y="5230368"/>
+            <a:ext cx="2615184" cy="1005840"/>
+          </a:xfrm>
+          <a:prstGeom prst="rect">
+            <a:avLst/>
+          </a:prstGeom>
+          <a:noFill/>
+        </p:spPr>
+        <p:txBody>
+          <a:bodyPr wrap="square" anchor="t" lIns="0" rIns="0" tIns="0" bIns="0">
+            <a:spAutoFit/>
+          </a:bodyPr>
+          <a:lstStyle/>
+          <a:p>
+            <a:pPr algn="l">
+              <a:lnSpc>
+                <a:spcPct val="108000"/>
+              </a:lnSpc>
+            </a:pPr>
+            <a:r>
+              <a:rPr sz="1150" b="0">
+                <a:solidFill>
+                  <a:srgbClr val="6B7586"/>
+                </a:solidFill>
+                <a:latin typeface="Segoe UI"/>
+              </a:rPr>
+              <a:t>On the breadboard: transformer leads in, IC regulator rail and Zener rail side by side.</a:t>
+            </a:r>
+          </a:p>
+        </p:txBody>
+      </p:sp>
+      <p:sp>
+        <p:nvSpPr>
+          <p:cNvPr id="21" name="TextBox 20"/>
+          <p:cNvSpPr txBox="1"/>
+          <p:nvPr/>
+        </p:nvSpPr>
+        <p:spPr>
+          <a:xfrm>
+            <a:off x="8869680" y="2921508"/>
+            <a:ext cx="182880" cy="365760"/>
           </a:xfrm>
           <a:prstGeom prst="rect">
             <a:avLst/>
@@ -5804,50 +5811,11 @@
             <a:r>
               <a:rPr sz="2200" b="0">
                 <a:solidFill>
-                  <a:srgbClr val="E9A23B"/>
+                  <a:srgbClr val="2A9D8F"/>
                 </a:solidFill>
                 <a:latin typeface="Segoe UI Semibold"/>
               </a:rPr>
-              <a:t>+5.3 %</a:t>
-            </a:r>
-          </a:p>
-        </p:txBody>
-      </p:sp>
-      <p:sp>
-        <p:nvSpPr>
-          <p:cNvPr id="21" name="TextBox 20"/>
-          <p:cNvSpPr txBox="1"/>
-          <p:nvPr/>
-        </p:nvSpPr>
-        <p:spPr>
-          <a:xfrm>
-            <a:off x="7251192" y="5678424"/>
-            <a:ext cx="2057400" cy="548640"/>
-          </a:xfrm>
-          <a:prstGeom prst="rect">
-            <a:avLst/>
-          </a:prstGeom>
-          <a:noFill/>
-        </p:spPr>
-        <p:txBody>
-          <a:bodyPr wrap="square" anchor="t" lIns="0" rIns="0" tIns="0" bIns="0">
-            <a:spAutoFit/>
-          </a:bodyPr>
-          <a:lstStyle/>
-          <a:p>
-            <a:pPr algn="l">
-              <a:lnSpc>
-                <a:spcPct val="105000"/>
-              </a:lnSpc>
-            </a:pPr>
-            <a:r>
-              <a:rPr sz="1100" b="0">
-                <a:solidFill>
-                  <a:srgbClr val="6B7586"/>
-                </a:solidFill>
-                <a:latin typeface="Segoe UI"/>
-              </a:rPr>
-              <a:t>Both RC cut-offs high: implies C ≈ 95 nF</a:t>
+              <a:t>›</a:t>
             </a:r>
           </a:p>
         </p:txBody>
@@ -5860,12 +5828,12 @@
         </p:nvSpPr>
         <p:spPr>
           <a:xfrm>
-            <a:off x="9518904" y="5074920"/>
-            <a:ext cx="2377440" cy="1188720"/>
+            <a:off x="9034272" y="1481328"/>
+            <a:ext cx="2615184" cy="3246120"/>
           </a:xfrm>
           <a:prstGeom prst="roundRect">
             <a:avLst>
-              <a:gd name="adj" fmla="val 8000"/>
+              <a:gd name="adj" fmla="val 4000"/>
             </a:avLst>
           </a:prstGeom>
           <a:solidFill>
@@ -5898,50 +5866,30 @@
           </a:p>
         </p:txBody>
       </p:sp>
-      <p:sp>
-        <p:nvSpPr>
-          <p:cNvPr id="23" name="Rectangle 22"/>
-          <p:cNvSpPr/>
-          <p:nvPr/>
-        </p:nvSpPr>
-        <p:spPr>
-          <a:xfrm>
-            <a:off x="9518904" y="5074920"/>
-            <a:ext cx="64008" cy="1188720"/>
-          </a:xfrm>
-          <a:prstGeom prst="rect">
-            <a:avLst/>
-          </a:prstGeom>
-          <a:solidFill>
-            <a:srgbClr val="2A9D8F"/>
-          </a:solidFill>
-          <a:ln>
-            <a:noFill/>
-          </a:ln>
-          <a:effectLst/>
-        </p:spPr>
-        <p:style>
-          <a:lnRef idx="1">
-            <a:schemeClr val="accent1"/>
-          </a:lnRef>
-          <a:fillRef idx="3">
-            <a:schemeClr val="accent1"/>
-          </a:fillRef>
-          <a:effectRef idx="2">
-            <a:schemeClr val="accent1"/>
-          </a:effectRef>
-          <a:fontRef idx="minor">
-            <a:schemeClr val="lt1"/>
-          </a:fontRef>
-        </p:style>
-        <p:txBody>
-          <a:bodyPr rtlCol="0" anchor="ctr"/>
-          <a:lstStyle/>
-          <a:p>
-            <a:pPr algn="ctr"/>
-          </a:p>
-        </p:txBody>
-      </p:sp>
+      <p:pic>
+        <p:nvPicPr>
+          <p:cNvPr id="23" name="Picture 22" descr="v2_p7_3.png"/>
+          <p:cNvPicPr>
+            <a:picLocks noChangeAspect="1"/>
+          </p:cNvPicPr>
+          <p:nvPr/>
+        </p:nvPicPr>
+        <p:blipFill>
+          <a:blip r:embed="rId5"/>
+          <a:stretch>
+            <a:fillRect/>
+          </a:stretch>
+        </p:blipFill>
+        <p:spPr>
+          <a:xfrm>
+            <a:off x="9143999" y="2119546"/>
+            <a:ext cx="2395728" cy="1969684"/>
+          </a:xfrm>
+          <a:prstGeom prst="rect">
+            <a:avLst/>
+          </a:prstGeom>
+        </p:spPr>
+      </p:pic>
       <p:sp>
         <p:nvSpPr>
           <p:cNvPr id="24" name="TextBox 23"/>
@@ -5950,8 +5898,8 @@
         </p:nvSpPr>
         <p:spPr>
           <a:xfrm>
-            <a:off x="9747504" y="5221224"/>
-            <a:ext cx="2057400" cy="457200"/>
+            <a:off x="9034272" y="4892040"/>
+            <a:ext cx="2615184" cy="320040"/>
           </a:xfrm>
           <a:prstGeom prst="rect">
             <a:avLst/>
@@ -5970,13 +5918,13 @@
               </a:lnSpc>
             </a:pPr>
             <a:r>
-              <a:rPr sz="2200" b="0">
-                <a:solidFill>
-                  <a:srgbClr val="2A9D8F"/>
+              <a:rPr sz="1400" b="0">
+                <a:solidFill>
+                  <a:srgbClr val="1F3A5F"/>
                 </a:solidFill>
                 <a:latin typeface="Segoe UI Semibold"/>
               </a:rPr>
-              <a:t>Q 0.66</a:t>
+              <a:t>4  ·  Measure</a:t>
             </a:r>
           </a:p>
         </p:txBody>
@@ -5989,33 +5937,33 @@
         </p:nvSpPr>
         <p:spPr>
           <a:xfrm>
-            <a:off x="9747504" y="5678424"/>
-            <a:ext cx="2057400" cy="548640"/>
-          </a:xfrm>
-          <a:prstGeom prst="rect">
-            <a:avLst/>
-          </a:prstGeom>
-          <a:noFill/>
-        </p:spPr>
-        <p:txBody>
-          <a:bodyPr wrap="square" anchor="t" lIns="0" rIns="0" tIns="0" bIns="0">
-            <a:spAutoFit/>
-          </a:bodyPr>
-          <a:lstStyle/>
-          <a:p>
-            <a:pPr algn="l">
-              <a:lnSpc>
-                <a:spcPct val="105000"/>
-              </a:lnSpc>
-            </a:pPr>
-            <a:r>
-              <a:rPr sz="1100" b="0">
+            <a:off x="9034272" y="5230368"/>
+            <a:ext cx="2615184" cy="1005840"/>
+          </a:xfrm>
+          <a:prstGeom prst="rect">
+            <a:avLst/>
+          </a:prstGeom>
+          <a:noFill/>
+        </p:spPr>
+        <p:txBody>
+          <a:bodyPr wrap="square" anchor="t" lIns="0" rIns="0" tIns="0" bIns="0">
+            <a:spAutoFit/>
+          </a:bodyPr>
+          <a:lstStyle/>
+          <a:p>
+            <a:pPr algn="l">
+              <a:lnSpc>
+                <a:spcPct val="108000"/>
+              </a:lnSpc>
+            </a:pPr>
+            <a:r>
+              <a:rPr sz="1150" b="0">
                 <a:solidFill>
                   <a:srgbClr val="6B7586"/>
                 </a:solidFill>
                 <a:latin typeface="Segoe UI"/>
               </a:rPr>
-              <a:t>Band-pass sharpness, theory 0.67</a:t>
+              <a:t>Scope in AC coupling on the − rail: 760 mV peak-to-peak ripple, the number that failed the spec.</a:t>
             </a:r>
           </a:p>
         </p:txBody>
@@ -6116,7 +6064,7 @@
                 </a:solidFill>
                 <a:latin typeface="Segoe UI Semibold"/>
               </a:rPr>
-              <a:t>PHYS 230 · ELECTRICITY AND MAGNETISM · LAB 4</a:t>
+              <a:t>ECE 203 · ELECTRICAL CIRCUITS II · LAB 6</a:t>
             </a:r>
           </a:p>
         </p:txBody>
@@ -6155,7 +6103,7 @@
                 </a:solidFill>
                 <a:latin typeface="Segoe UI Semibold"/>
               </a:rPr>
-              <a:t>Faraday's law, two ways</a:t>
+              <a:t>Four filters, measured against the math</a:t>
             </a:r>
           </a:p>
         </p:txBody>
@@ -6194,7 +6142,7 @@
                 </a:solidFill>
                 <a:latin typeface="Segoe UI"/>
               </a:rPr>
-              <a:t>With lab partners Duong Hung Nguyen and James Pacia. Report written individually (Mar 2026).</a:t>
+              <a:t>Individual results sheet (Mar 2026). Measured points from my tables; theory uses the nominal 470 Ω, 100 nF, 10 mH.</a:t>
             </a:r>
           </a:p>
         </p:txBody>
@@ -6233,7 +6181,7 @@
                 </a:solidFill>
                 <a:latin typeface="Segoe UI"/>
               </a:rPr>
-              <a:t>4 / 6</a:t>
+              <a:t>4 / 7</a:t>
             </a:r>
           </a:p>
         </p:txBody>
@@ -6311,7 +6259,7 @@
                 </a:solidFill>
                 <a:latin typeface="Segoe UI"/>
               </a:rPr>
-              <a:t>Is induced EMF proportional to the rate of change of flux, and can a flipped coil measure Earth's magnetic field?</a:t>
+              <a:t>Do real RC, RL and RLC filters cut off where 1/(2πRC), R/(2πL) and 1/(2π√LC) say they should?</a:t>
             </a:r>
           </a:p>
         </p:txBody>
@@ -6389,7 +6337,7 @@
                 </a:solidFill>
                 <a:latin typeface="Segoe UI"/>
               </a:rPr>
-              <a:t>Ten 180° flips of a 100-turn coil through a ×200 amplifier; then 11 current settings on coupled solenoids, fit with LINEST in Excel.</a:t>
+              <a:t>Swept each filter from 100 Hz to 100 kHz on the function generator and scope, and found each −3 dB point.</a:t>
             </a:r>
           </a:p>
         </p:txBody>
@@ -6402,7 +6350,7 @@
         </p:nvSpPr>
         <p:spPr>
           <a:xfrm>
-            <a:off x="640080" y="4206240"/>
+            <a:off x="640080" y="3968496"/>
             <a:ext cx="3566160" cy="274320"/>
           </a:xfrm>
           <a:prstGeom prst="rect">
@@ -6441,7 +6389,7 @@
         </p:nvSpPr>
         <p:spPr>
           <a:xfrm>
-            <a:off x="640080" y="4453128"/>
+            <a:off x="640080" y="4215384"/>
             <a:ext cx="3566160" cy="1280160"/>
           </a:xfrm>
           <a:prstGeom prst="rect">
@@ -6467,14 +6415,14 @@
                 </a:solidFill>
                 <a:latin typeface="Segoe UI"/>
               </a:rPr>
-              <a:t>Induced voltage is linear in current (R² = 0.9998). The flip coil gave B 32 % above the gaussmeter; likely local interference and coil alignment.</a:t>
+              <a:t>Every corner landed within 5.4 % of theory. Both RC cut-offs ran high by the same 5 %, consistent with the capacitor being about 95 nF (within its tolerance).</a:t>
             </a:r>
           </a:p>
         </p:txBody>
       </p:sp>
       <p:pic>
         <p:nvPicPr>
-          <p:cNvPr id="13" name="Picture 12" descr="lab_faraday.png"/>
+          <p:cNvPr id="13" name="Picture 12" descr="lab_filters.png"/>
           <p:cNvPicPr>
             <a:picLocks noChangeAspect="1"/>
           </p:cNvPicPr>
@@ -6488,8 +6436,8 @@
         </p:blipFill>
         <p:spPr>
           <a:xfrm>
-            <a:off x="4526280" y="1463040"/>
-            <a:ext cx="7315200" cy="2878637"/>
+            <a:off x="4526280" y="1325880"/>
+            <a:ext cx="5820966" cy="3611880"/>
           </a:xfrm>
           <a:prstGeom prst="rect">
             <a:avLst/>
@@ -6620,7 +6568,7 @@
                 </a:solidFill>
                 <a:latin typeface="Segoe UI Semibold"/>
               </a:rPr>
-              <a:t>R² 0.9998</a:t>
+              <a:t>−0.4 %</a:t>
             </a:r>
           </a:p>
         </p:txBody>
@@ -6659,7 +6607,7 @@
                 </a:solidFill>
                 <a:latin typeface="Segoe UI"/>
               </a:rPr>
-              <a:t>Linear fit, induced EMF vs primary current</a:t>
+              <a:t>RLC centre frequency vs theory (5,013 vs 5,033 Hz)</a:t>
             </a:r>
           </a:p>
         </p:txBody>
@@ -6725,7 +6673,7 @@
             <a:avLst/>
           </a:prstGeom>
           <a:solidFill>
-            <a:srgbClr val="2A9D8F"/>
+            <a:srgbClr val="E9A23B"/>
           </a:solidFill>
           <a:ln>
             <a:noFill/>
@@ -6784,11 +6732,11 @@
             <a:r>
               <a:rPr sz="2200" b="0">
                 <a:solidFill>
-                  <a:srgbClr val="2A9D8F"/>
+                  <a:srgbClr val="E9A23B"/>
                 </a:solidFill>
                 <a:latin typeface="Segoe UI Semibold"/>
               </a:rPr>
-              <a:t>3.23 ± 0.09</a:t>
+              <a:t>+5.3 %</a:t>
             </a:r>
           </a:p>
         </p:txBody>
@@ -6827,7 +6775,7 @@
                 </a:solidFill>
                 <a:latin typeface="Segoe UI"/>
               </a:rPr>
-              <a:t>Earth's field, ×10⁻⁵ T (fractional error propagation)</a:t>
+              <a:t>Both RC cut-offs high: implies C ≈ 95 nF</a:t>
             </a:r>
           </a:p>
         </p:txBody>
@@ -6893,7 +6841,7 @@
             <a:avLst/>
           </a:prstGeom>
           <a:solidFill>
-            <a:srgbClr val="6B7586"/>
+            <a:srgbClr val="2A9D8F"/>
           </a:solidFill>
           <a:ln>
             <a:noFill/>
@@ -6952,11 +6900,11 @@
             <a:r>
               <a:rPr sz="2200" b="0">
                 <a:solidFill>
-                  <a:srgbClr val="6B7586"/>
+                  <a:srgbClr val="2A9D8F"/>
                 </a:solidFill>
                 <a:latin typeface="Segoe UI Semibold"/>
               </a:rPr>
-              <a:t>2.45</a:t>
+              <a:t>Q 0.66</a:t>
             </a:r>
           </a:p>
         </p:txBody>
@@ -6995,7 +6943,7 @@
                 </a:solidFill>
                 <a:latin typeface="Segoe UI"/>
               </a:rPr>
-              <a:t>Gaussmeter reference, ×10⁻⁵ T</a:t>
+              <a:t>Band-pass sharpness, theory 0.67</a:t>
             </a:r>
           </a:p>
         </p:txBody>
@@ -7096,7 +7044,7 @@
                 </a:solidFill>
                 <a:latin typeface="Segoe UI Semibold"/>
               </a:rPr>
-              <a:t>ECE 340 · DISCRETE-TIME SIGNALS AND SYSTEMS · LAB 2</a:t>
+              <a:t>PHYS 230 · ELECTRICITY AND MAGNETISM · LAB 4</a:t>
             </a:r>
           </a:p>
         </p:txBody>
@@ -7135,7 +7083,7 @@
                 </a:solidFill>
                 <a:latin typeface="Segoe UI Semibold"/>
               </a:rPr>
-              <a:t>When 90 Hz turns into 10 Hz</a:t>
+              <a:t>Faraday's law, two ways</a:t>
             </a:r>
           </a:p>
         </p:txBody>
@@ -7174,7 +7122,7 @@
                 </a:solidFill>
                 <a:latin typeface="Segoe UI"/>
               </a:rPr>
-              <a:t>Individual report (Oct 2026). Top graph redrawn from the lab's signal definitions; the images are my MATLAB output.</a:t>
+              <a:t>With lab partners Duong Hung Nguyen and James Pacia. Report written individually (Mar 2026).</a:t>
             </a:r>
           </a:p>
         </p:txBody>
@@ -7213,7 +7161,7 @@
                 </a:solidFill>
                 <a:latin typeface="Segoe UI"/>
               </a:rPr>
-              <a:t>5 / 6</a:t>
+              <a:t>5 / 7</a:t>
             </a:r>
           </a:p>
         </p:txBody>
@@ -7291,7 +7239,7 @@
                 </a:solidFill>
                 <a:latin typeface="Segoe UI"/>
               </a:rPr>
-              <a:t>What happens when a signal is sampled slower than twice its highest frequency, in 1D and in images?</a:t>
+              <a:t>Is induced EMF proportional to the rate of change of flux, and can a flipped coil measure Earth's magnetic field?</a:t>
             </a:r>
           </a:p>
         </p:txBody>
@@ -7369,7 +7317,7 @@
                 </a:solidFill>
                 <a:latin typeface="Segoe UI"/>
               </a:rPr>
-              <a:t>Sampled 10 Hz and 90 Hz cosines at 100 Hz and 1 kHz in MATLAB, then shrank a test image with anti-aliasing off and on.</a:t>
+              <a:t>Ten 180° flips of a 100-turn coil through a ×200 amplifier; then 11 current settings on coupled solenoids, fit with LINEST in Excel.</a:t>
             </a:r>
           </a:p>
         </p:txBody>
@@ -7447,14 +7395,14 @@
                 </a:solidFill>
                 <a:latin typeface="Segoe UI"/>
               </a:rPr>
-              <a:t>At 100 Hz the two tones give identical samples (max difference 1.7×10⁻¹⁴). Shrinking an image is resampling too: fine stripes alias into moiré unless low-passed first.</a:t>
+              <a:t>Induced voltage is linear in current (R² = 0.9998). The flip coil gave B 32 % above the gaussmeter; likely local interference and coil alignment.</a:t>
             </a:r>
           </a:p>
         </p:txBody>
       </p:sp>
       <p:pic>
         <p:nvPicPr>
-          <p:cNvPr id="13" name="Picture 12" descr="lab_alias.png"/>
+          <p:cNvPr id="13" name="Picture 12" descr="lab_faraday.png"/>
           <p:cNvPicPr>
             <a:picLocks noChangeAspect="1"/>
           </p:cNvPicPr>
@@ -7468,48 +7416,114 @@
         </p:blipFill>
         <p:spPr>
           <a:xfrm>
-            <a:off x="4526280" y="1371600"/>
-            <a:ext cx="7315200" cy="2451217"/>
+            <a:off x="4526280" y="1463040"/>
+            <a:ext cx="7315200" cy="2878637"/>
           </a:xfrm>
           <a:prstGeom prst="rect">
             <a:avLst/>
           </a:prstGeom>
         </p:spPr>
       </p:pic>
-      <p:pic>
-        <p:nvPicPr>
-          <p:cNvPr id="14" name="Picture 13" descr="lab_alias_img.png"/>
-          <p:cNvPicPr>
-            <a:picLocks noChangeAspect="1"/>
-          </p:cNvPicPr>
-          <p:nvPr/>
-        </p:nvPicPr>
-        <p:blipFill>
-          <a:blip r:embed="rId3"/>
-          <a:stretch>
-            <a:fillRect/>
-          </a:stretch>
-        </p:blipFill>
-        <p:spPr>
-          <a:xfrm>
-            <a:off x="4526280" y="3977639"/>
-            <a:ext cx="4324786" cy="2331720"/>
-          </a:xfrm>
-          <a:prstGeom prst="rect">
-            <a:avLst/>
-          </a:prstGeom>
-        </p:spPr>
-      </p:pic>
-      <p:sp>
-        <p:nvSpPr>
-          <p:cNvPr id="15" name="TextBox 14"/>
-          <p:cNvSpPr txBox="1"/>
-          <p:nvPr/>
-        </p:nvSpPr>
-        <p:spPr>
-          <a:xfrm>
-            <a:off x="8961120" y="4206240"/>
-            <a:ext cx="2926080" cy="2011680"/>
+      <p:sp>
+        <p:nvSpPr>
+          <p:cNvPr id="14" name="Rounded Rectangle 13"/>
+          <p:cNvSpPr/>
+          <p:nvPr/>
+        </p:nvSpPr>
+        <p:spPr>
+          <a:xfrm>
+            <a:off x="4526280" y="5074920"/>
+            <a:ext cx="2377440" cy="1188720"/>
+          </a:xfrm>
+          <a:prstGeom prst="roundRect">
+            <a:avLst>
+              <a:gd name="adj" fmla="val 8000"/>
+            </a:avLst>
+          </a:prstGeom>
+          <a:solidFill>
+            <a:srgbClr val="EEF2F6"/>
+          </a:solidFill>
+          <a:ln>
+            <a:noFill/>
+          </a:ln>
+          <a:effectLst/>
+        </p:spPr>
+        <p:style>
+          <a:lnRef idx="1">
+            <a:schemeClr val="accent1"/>
+          </a:lnRef>
+          <a:fillRef idx="3">
+            <a:schemeClr val="accent1"/>
+          </a:fillRef>
+          <a:effectRef idx="2">
+            <a:schemeClr val="accent1"/>
+          </a:effectRef>
+          <a:fontRef idx="minor">
+            <a:schemeClr val="lt1"/>
+          </a:fontRef>
+        </p:style>
+        <p:txBody>
+          <a:bodyPr rtlCol="0" anchor="ctr"/>
+          <a:lstStyle/>
+          <a:p>
+            <a:pPr algn="ctr"/>
+          </a:p>
+        </p:txBody>
+      </p:sp>
+      <p:sp>
+        <p:nvSpPr>
+          <p:cNvPr id="15" name="Rectangle 14"/>
+          <p:cNvSpPr/>
+          <p:nvPr/>
+        </p:nvSpPr>
+        <p:spPr>
+          <a:xfrm>
+            <a:off x="4526280" y="5074920"/>
+            <a:ext cx="64008" cy="1188720"/>
+          </a:xfrm>
+          <a:prstGeom prst="rect">
+            <a:avLst/>
+          </a:prstGeom>
+          <a:solidFill>
+            <a:srgbClr val="1F3A5F"/>
+          </a:solidFill>
+          <a:ln>
+            <a:noFill/>
+          </a:ln>
+          <a:effectLst/>
+        </p:spPr>
+        <p:style>
+          <a:lnRef idx="1">
+            <a:schemeClr val="accent1"/>
+          </a:lnRef>
+          <a:fillRef idx="3">
+            <a:schemeClr val="accent1"/>
+          </a:fillRef>
+          <a:effectRef idx="2">
+            <a:schemeClr val="accent1"/>
+          </a:effectRef>
+          <a:fontRef idx="minor">
+            <a:schemeClr val="lt1"/>
+          </a:fontRef>
+        </p:style>
+        <p:txBody>
+          <a:bodyPr rtlCol="0" anchor="ctr"/>
+          <a:lstStyle/>
+          <a:p>
+            <a:pPr algn="ctr"/>
+          </a:p>
+        </p:txBody>
+      </p:sp>
+      <p:sp>
+        <p:nvSpPr>
+          <p:cNvPr id="16" name="TextBox 15"/>
+          <p:cNvSpPr txBox="1"/>
+          <p:nvPr/>
+        </p:nvSpPr>
+        <p:spPr>
+          <a:xfrm>
+            <a:off x="4754880" y="5221224"/>
+            <a:ext cx="2057400" cy="457200"/>
           </a:xfrm>
           <a:prstGeom prst="rect">
             <a:avLst/>
@@ -7528,50 +7542,388 @@
               </a:lnSpc>
             </a:pPr>
             <a:r>
-              <a:rPr sz="1250" b="1">
-                <a:solidFill>
-                  <a:srgbClr val="1E2430"/>
+              <a:rPr sz="2200" b="0">
+                <a:solidFill>
+                  <a:srgbClr val="1F3A5F"/>
+                </a:solidFill>
+                <a:latin typeface="Segoe UI Semibold"/>
+              </a:rPr>
+              <a:t>R² 0.9998</a:t>
+            </a:r>
+          </a:p>
+        </p:txBody>
+      </p:sp>
+      <p:sp>
+        <p:nvSpPr>
+          <p:cNvPr id="17" name="TextBox 16"/>
+          <p:cNvSpPr txBox="1"/>
+          <p:nvPr/>
+        </p:nvSpPr>
+        <p:spPr>
+          <a:xfrm>
+            <a:off x="4754880" y="5678424"/>
+            <a:ext cx="2057400" cy="548640"/>
+          </a:xfrm>
+          <a:prstGeom prst="rect">
+            <a:avLst/>
+          </a:prstGeom>
+          <a:noFill/>
+        </p:spPr>
+        <p:txBody>
+          <a:bodyPr wrap="square" anchor="t" lIns="0" rIns="0" tIns="0" bIns="0">
+            <a:spAutoFit/>
+          </a:bodyPr>
+          <a:lstStyle/>
+          <a:p>
+            <a:pPr algn="l">
+              <a:lnSpc>
+                <a:spcPct val="105000"/>
+              </a:lnSpc>
+            </a:pPr>
+            <a:r>
+              <a:rPr sz="1100" b="0">
+                <a:solidFill>
+                  <a:srgbClr val="6B7586"/>
                 </a:solidFill>
                 <a:latin typeface="Segoe UI"/>
               </a:rPr>
-              <a:t>Left:</a:t>
-            </a:r>
-            <a:r>
-              <a:rPr sz="1250" b="0">
-                <a:solidFill>
-                  <a:srgbClr val="1E2430"/>
+              <a:t>Linear fit, induced EMF vs primary current</a:t>
+            </a:r>
+          </a:p>
+        </p:txBody>
+      </p:sp>
+      <p:sp>
+        <p:nvSpPr>
+          <p:cNvPr id="18" name="Rounded Rectangle 17"/>
+          <p:cNvSpPr/>
+          <p:nvPr/>
+        </p:nvSpPr>
+        <p:spPr>
+          <a:xfrm>
+            <a:off x="7022592" y="5074920"/>
+            <a:ext cx="2377440" cy="1188720"/>
+          </a:xfrm>
+          <a:prstGeom prst="roundRect">
+            <a:avLst>
+              <a:gd name="adj" fmla="val 8000"/>
+            </a:avLst>
+          </a:prstGeom>
+          <a:solidFill>
+            <a:srgbClr val="EEF2F6"/>
+          </a:solidFill>
+          <a:ln>
+            <a:noFill/>
+          </a:ln>
+          <a:effectLst/>
+        </p:spPr>
+        <p:style>
+          <a:lnRef idx="1">
+            <a:schemeClr val="accent1"/>
+          </a:lnRef>
+          <a:fillRef idx="3">
+            <a:schemeClr val="accent1"/>
+          </a:fillRef>
+          <a:effectRef idx="2">
+            <a:schemeClr val="accent1"/>
+          </a:effectRef>
+          <a:fontRef idx="minor">
+            <a:schemeClr val="lt1"/>
+          </a:fontRef>
+        </p:style>
+        <p:txBody>
+          <a:bodyPr rtlCol="0" anchor="ctr"/>
+          <a:lstStyle/>
+          <a:p>
+            <a:pPr algn="ctr"/>
+          </a:p>
+        </p:txBody>
+      </p:sp>
+      <p:sp>
+        <p:nvSpPr>
+          <p:cNvPr id="19" name="Rectangle 18"/>
+          <p:cNvSpPr/>
+          <p:nvPr/>
+        </p:nvSpPr>
+        <p:spPr>
+          <a:xfrm>
+            <a:off x="7022592" y="5074920"/>
+            <a:ext cx="64008" cy="1188720"/>
+          </a:xfrm>
+          <a:prstGeom prst="rect">
+            <a:avLst/>
+          </a:prstGeom>
+          <a:solidFill>
+            <a:srgbClr val="2A9D8F"/>
+          </a:solidFill>
+          <a:ln>
+            <a:noFill/>
+          </a:ln>
+          <a:effectLst/>
+        </p:spPr>
+        <p:style>
+          <a:lnRef idx="1">
+            <a:schemeClr val="accent1"/>
+          </a:lnRef>
+          <a:fillRef idx="3">
+            <a:schemeClr val="accent1"/>
+          </a:fillRef>
+          <a:effectRef idx="2">
+            <a:schemeClr val="accent1"/>
+          </a:effectRef>
+          <a:fontRef idx="minor">
+            <a:schemeClr val="lt1"/>
+          </a:fontRef>
+        </p:style>
+        <p:txBody>
+          <a:bodyPr rtlCol="0" anchor="ctr"/>
+          <a:lstStyle/>
+          <a:p>
+            <a:pPr algn="ctr"/>
+          </a:p>
+        </p:txBody>
+      </p:sp>
+      <p:sp>
+        <p:nvSpPr>
+          <p:cNvPr id="20" name="TextBox 19"/>
+          <p:cNvSpPr txBox="1"/>
+          <p:nvPr/>
+        </p:nvSpPr>
+        <p:spPr>
+          <a:xfrm>
+            <a:off x="7251192" y="5221224"/>
+            <a:ext cx="2057400" cy="457200"/>
+          </a:xfrm>
+          <a:prstGeom prst="rect">
+            <a:avLst/>
+          </a:prstGeom>
+          <a:noFill/>
+        </p:spPr>
+        <p:txBody>
+          <a:bodyPr wrap="square" anchor="t" lIns="0" rIns="0" tIns="0" bIns="0">
+            <a:spAutoFit/>
+          </a:bodyPr>
+          <a:lstStyle/>
+          <a:p>
+            <a:pPr algn="l">
+              <a:lnSpc>
+                <a:spcPct val="110000"/>
+              </a:lnSpc>
+            </a:pPr>
+            <a:r>
+              <a:rPr sz="2200" b="0">
+                <a:solidFill>
+                  <a:srgbClr val="2A9D8F"/>
+                </a:solidFill>
+                <a:latin typeface="Segoe UI Semibold"/>
+              </a:rPr>
+              <a:t>3.23 ± 0.09</a:t>
+            </a:r>
+          </a:p>
+        </p:txBody>
+      </p:sp>
+      <p:sp>
+        <p:nvSpPr>
+          <p:cNvPr id="21" name="TextBox 20"/>
+          <p:cNvSpPr txBox="1"/>
+          <p:nvPr/>
+        </p:nvSpPr>
+        <p:spPr>
+          <a:xfrm>
+            <a:off x="7251192" y="5678424"/>
+            <a:ext cx="2057400" cy="548640"/>
+          </a:xfrm>
+          <a:prstGeom prst="rect">
+            <a:avLst/>
+          </a:prstGeom>
+          <a:noFill/>
+        </p:spPr>
+        <p:txBody>
+          <a:bodyPr wrap="square" anchor="t" lIns="0" rIns="0" tIns="0" bIns="0">
+            <a:spAutoFit/>
+          </a:bodyPr>
+          <a:lstStyle/>
+          <a:p>
+            <a:pPr algn="l">
+              <a:lnSpc>
+                <a:spcPct val="105000"/>
+              </a:lnSpc>
+            </a:pPr>
+            <a:r>
+              <a:rPr sz="1100" b="0">
+                <a:solidFill>
+                  <a:srgbClr val="6B7586"/>
                 </a:solidFill>
                 <a:latin typeface="Segoe UI"/>
               </a:rPr>
-              <a:t> stripes on the clothing turn into false wavy bands.</a:t>
-            </a:r>
-          </a:p>
+              <a:t>Earth's field, ×10⁻⁵ T (fractional error propagation)</a:t>
+            </a:r>
+          </a:p>
+        </p:txBody>
+      </p:sp>
+      <p:sp>
+        <p:nvSpPr>
+          <p:cNvPr id="22" name="Rounded Rectangle 21"/>
+          <p:cNvSpPr/>
+          <p:nvPr/>
+        </p:nvSpPr>
+        <p:spPr>
+          <a:xfrm>
+            <a:off x="9518904" y="5074920"/>
+            <a:ext cx="2377440" cy="1188720"/>
+          </a:xfrm>
+          <a:prstGeom prst="roundRect">
+            <a:avLst>
+              <a:gd name="adj" fmla="val 8000"/>
+            </a:avLst>
+          </a:prstGeom>
+          <a:solidFill>
+            <a:srgbClr val="EEF2F6"/>
+          </a:solidFill>
+          <a:ln>
+            <a:noFill/>
+          </a:ln>
+          <a:effectLst/>
+        </p:spPr>
+        <p:style>
+          <a:lnRef idx="1">
+            <a:schemeClr val="accent1"/>
+          </a:lnRef>
+          <a:fillRef idx="3">
+            <a:schemeClr val="accent1"/>
+          </a:fillRef>
+          <a:effectRef idx="2">
+            <a:schemeClr val="accent1"/>
+          </a:effectRef>
+          <a:fontRef idx="minor">
+            <a:schemeClr val="lt1"/>
+          </a:fontRef>
+        </p:style>
+        <p:txBody>
+          <a:bodyPr rtlCol="0" anchor="ctr"/>
+          <a:lstStyle/>
+          <a:p>
+            <a:pPr algn="ctr"/>
+          </a:p>
+        </p:txBody>
+      </p:sp>
+      <p:sp>
+        <p:nvSpPr>
+          <p:cNvPr id="23" name="Rectangle 22"/>
+          <p:cNvSpPr/>
+          <p:nvPr/>
+        </p:nvSpPr>
+        <p:spPr>
+          <a:xfrm>
+            <a:off x="9518904" y="5074920"/>
+            <a:ext cx="64008" cy="1188720"/>
+          </a:xfrm>
+          <a:prstGeom prst="rect">
+            <a:avLst/>
+          </a:prstGeom>
+          <a:solidFill>
+            <a:srgbClr val="6B7586"/>
+          </a:solidFill>
+          <a:ln>
+            <a:noFill/>
+          </a:ln>
+          <a:effectLst/>
+        </p:spPr>
+        <p:style>
+          <a:lnRef idx="1">
+            <a:schemeClr val="accent1"/>
+          </a:lnRef>
+          <a:fillRef idx="3">
+            <a:schemeClr val="accent1"/>
+          </a:fillRef>
+          <a:effectRef idx="2">
+            <a:schemeClr val="accent1"/>
+          </a:effectRef>
+          <a:fontRef idx="minor">
+            <a:schemeClr val="lt1"/>
+          </a:fontRef>
+        </p:style>
+        <p:txBody>
+          <a:bodyPr rtlCol="0" anchor="ctr"/>
+          <a:lstStyle/>
+          <a:p>
+            <a:pPr algn="ctr"/>
+          </a:p>
+        </p:txBody>
+      </p:sp>
+      <p:sp>
+        <p:nvSpPr>
+          <p:cNvPr id="24" name="TextBox 23"/>
+          <p:cNvSpPr txBox="1"/>
+          <p:nvPr/>
+        </p:nvSpPr>
+        <p:spPr>
+          <a:xfrm>
+            <a:off x="9747504" y="5221224"/>
+            <a:ext cx="2057400" cy="457200"/>
+          </a:xfrm>
+          <a:prstGeom prst="rect">
+            <a:avLst/>
+          </a:prstGeom>
+          <a:noFill/>
+        </p:spPr>
+        <p:txBody>
+          <a:bodyPr wrap="square" anchor="t" lIns="0" rIns="0" tIns="0" bIns="0">
+            <a:spAutoFit/>
+          </a:bodyPr>
+          <a:lstStyle/>
           <a:p>
             <a:pPr algn="l">
               <a:lnSpc>
                 <a:spcPct val="110000"/>
               </a:lnSpc>
-              <a:spcBef>
-                <a:spcPts val="600"/>
-              </a:spcBef>
-            </a:pPr>
-            <a:r>
-              <a:rPr sz="1250" b="1">
-                <a:solidFill>
-                  <a:srgbClr val="1E2430"/>
+            </a:pPr>
+            <a:r>
+              <a:rPr sz="2200" b="0">
+                <a:solidFill>
+                  <a:srgbClr val="6B7586"/>
+                </a:solidFill>
+                <a:latin typeface="Segoe UI Semibold"/>
+              </a:rPr>
+              <a:t>2.45</a:t>
+            </a:r>
+          </a:p>
+        </p:txBody>
+      </p:sp>
+      <p:sp>
+        <p:nvSpPr>
+          <p:cNvPr id="25" name="TextBox 24"/>
+          <p:cNvSpPr txBox="1"/>
+          <p:nvPr/>
+        </p:nvSpPr>
+        <p:spPr>
+          <a:xfrm>
+            <a:off x="9747504" y="5678424"/>
+            <a:ext cx="2057400" cy="548640"/>
+          </a:xfrm>
+          <a:prstGeom prst="rect">
+            <a:avLst/>
+          </a:prstGeom>
+          <a:noFill/>
+        </p:spPr>
+        <p:txBody>
+          <a:bodyPr wrap="square" anchor="t" lIns="0" rIns="0" tIns="0" bIns="0">
+            <a:spAutoFit/>
+          </a:bodyPr>
+          <a:lstStyle/>
+          <a:p>
+            <a:pPr algn="l">
+              <a:lnSpc>
+                <a:spcPct val="105000"/>
+              </a:lnSpc>
+            </a:pPr>
+            <a:r>
+              <a:rPr sz="1100" b="0">
+                <a:solidFill>
+                  <a:srgbClr val="6B7586"/>
                 </a:solidFill>
                 <a:latin typeface="Segoe UI"/>
               </a:rPr>
-              <a:t>Right:</a:t>
-            </a:r>
-            <a:r>
-              <a:rPr sz="1250" b="0">
-                <a:solidFill>
-                  <a:srgbClr val="1E2430"/>
-                </a:solidFill>
-                <a:latin typeface="Segoe UI"/>
-              </a:rPr>
-              <a:t> filtered first, they fade to grey instead. Cost: a little blur.</a:t>
+              <a:t>Gaussmeter reference, ×10⁻⁵ T</a:t>
             </a:r>
           </a:p>
         </p:txBody>
@@ -7585,6 +7937,582 @@
 </file>
 
 <file path=ppt/slides/slide6.xml><?xml version="1.0" encoding="utf-8"?>
+<p:sld xmlns:a="http://schemas.openxmlformats.org/drawingml/2006/main" xmlns:p="http://schemas.openxmlformats.org/presentationml/2006/main" xmlns:r="http://schemas.openxmlformats.org/officeDocument/2006/relationships">
+  <p:cSld>
+    <p:spTree>
+      <p:nvGrpSpPr>
+        <p:cNvPr id="1" name=""/>
+        <p:cNvGrpSpPr/>
+        <p:nvPr/>
+      </p:nvGrpSpPr>
+      <p:grpSpPr/>
+      <p:sp>
+        <p:nvSpPr>
+          <p:cNvPr id="2" name="Rectangle 1"/>
+          <p:cNvSpPr/>
+          <p:nvPr/>
+        </p:nvSpPr>
+        <p:spPr>
+          <a:xfrm>
+            <a:off x="0" y="0"/>
+            <a:ext cx="164592" cy="6858000"/>
+          </a:xfrm>
+          <a:prstGeom prst="rect">
+            <a:avLst/>
+          </a:prstGeom>
+          <a:solidFill>
+            <a:srgbClr val="1F3A5F"/>
+          </a:solidFill>
+          <a:ln>
+            <a:noFill/>
+          </a:ln>
+          <a:effectLst/>
+        </p:spPr>
+        <p:style>
+          <a:lnRef idx="1">
+            <a:schemeClr val="accent1"/>
+          </a:lnRef>
+          <a:fillRef idx="3">
+            <a:schemeClr val="accent1"/>
+          </a:fillRef>
+          <a:effectRef idx="2">
+            <a:schemeClr val="accent1"/>
+          </a:effectRef>
+          <a:fontRef idx="minor">
+            <a:schemeClr val="lt1"/>
+          </a:fontRef>
+        </p:style>
+        <p:txBody>
+          <a:bodyPr rtlCol="0" anchor="ctr"/>
+          <a:lstStyle/>
+          <a:p>
+            <a:pPr algn="ctr"/>
+          </a:p>
+        </p:txBody>
+      </p:sp>
+      <p:sp>
+        <p:nvSpPr>
+          <p:cNvPr id="3" name="TextBox 2"/>
+          <p:cNvSpPr txBox="1"/>
+          <p:nvPr/>
+        </p:nvSpPr>
+        <p:spPr>
+          <a:xfrm>
+            <a:off x="640080" y="365760"/>
+            <a:ext cx="8229600" cy="274320"/>
+          </a:xfrm>
+          <a:prstGeom prst="rect">
+            <a:avLst/>
+          </a:prstGeom>
+          <a:noFill/>
+        </p:spPr>
+        <p:txBody>
+          <a:bodyPr wrap="square" anchor="t" lIns="0" rIns="0" tIns="0" bIns="0">
+            <a:spAutoFit/>
+          </a:bodyPr>
+          <a:lstStyle/>
+          <a:p>
+            <a:pPr algn="l">
+              <a:lnSpc>
+                <a:spcPct val="110000"/>
+              </a:lnSpc>
+            </a:pPr>
+            <a:r>
+              <a:rPr sz="1100" b="0">
+                <a:solidFill>
+                  <a:srgbClr val="2A9D8F"/>
+                </a:solidFill>
+                <a:latin typeface="Segoe UI Semibold"/>
+              </a:rPr>
+              <a:t>ECE 340 · DISCRETE-TIME SIGNALS AND SYSTEMS · LAB 2</a:t>
+            </a:r>
+          </a:p>
+        </p:txBody>
+      </p:sp>
+      <p:sp>
+        <p:nvSpPr>
+          <p:cNvPr id="4" name="TextBox 3"/>
+          <p:cNvSpPr txBox="1"/>
+          <p:nvPr/>
+        </p:nvSpPr>
+        <p:spPr>
+          <a:xfrm>
+            <a:off x="640080" y="603504"/>
+            <a:ext cx="10972800" cy="731520"/>
+          </a:xfrm>
+          <a:prstGeom prst="rect">
+            <a:avLst/>
+          </a:prstGeom>
+          <a:noFill/>
+        </p:spPr>
+        <p:txBody>
+          <a:bodyPr wrap="square" anchor="t" lIns="0" rIns="0" tIns="0" bIns="0">
+            <a:spAutoFit/>
+          </a:bodyPr>
+          <a:lstStyle/>
+          <a:p>
+            <a:pPr algn="l">
+              <a:lnSpc>
+                <a:spcPct val="110000"/>
+              </a:lnSpc>
+            </a:pPr>
+            <a:r>
+              <a:rPr sz="2800" b="0">
+                <a:solidFill>
+                  <a:srgbClr val="1F3A5F"/>
+                </a:solidFill>
+                <a:latin typeface="Segoe UI Semibold"/>
+              </a:rPr>
+              <a:t>When 90 Hz turns into 10 Hz</a:t>
+            </a:r>
+          </a:p>
+        </p:txBody>
+      </p:sp>
+      <p:sp>
+        <p:nvSpPr>
+          <p:cNvPr id="5" name="TextBox 4"/>
+          <p:cNvSpPr txBox="1"/>
+          <p:nvPr/>
+        </p:nvSpPr>
+        <p:spPr>
+          <a:xfrm>
+            <a:off x="640080" y="6419088"/>
+            <a:ext cx="8229600" cy="274320"/>
+          </a:xfrm>
+          <a:prstGeom prst="rect">
+            <a:avLst/>
+          </a:prstGeom>
+          <a:noFill/>
+        </p:spPr>
+        <p:txBody>
+          <a:bodyPr wrap="square" anchor="t" lIns="0" rIns="0" tIns="0" bIns="0">
+            <a:spAutoFit/>
+          </a:bodyPr>
+          <a:lstStyle/>
+          <a:p>
+            <a:pPr algn="l">
+              <a:lnSpc>
+                <a:spcPct val="110000"/>
+              </a:lnSpc>
+            </a:pPr>
+            <a:r>
+              <a:rPr sz="1000" b="0">
+                <a:solidFill>
+                  <a:srgbClr val="6B7586"/>
+                </a:solidFill>
+                <a:latin typeface="Segoe UI"/>
+              </a:rPr>
+              <a:t>Individual report (Oct 2026). Top graph redrawn from the lab's signal definitions; the images are my MATLAB output.</a:t>
+            </a:r>
+          </a:p>
+        </p:txBody>
+      </p:sp>
+      <p:sp>
+        <p:nvSpPr>
+          <p:cNvPr id="6" name="TextBox 5"/>
+          <p:cNvSpPr txBox="1"/>
+          <p:nvPr/>
+        </p:nvSpPr>
+        <p:spPr>
+          <a:xfrm>
+            <a:off x="10607040" y="6419088"/>
+            <a:ext cx="1097280" cy="274320"/>
+          </a:xfrm>
+          <a:prstGeom prst="rect">
+            <a:avLst/>
+          </a:prstGeom>
+          <a:noFill/>
+        </p:spPr>
+        <p:txBody>
+          <a:bodyPr wrap="square" anchor="t" lIns="0" rIns="0" tIns="0" bIns="0">
+            <a:spAutoFit/>
+          </a:bodyPr>
+          <a:lstStyle/>
+          <a:p>
+            <a:pPr algn="r">
+              <a:lnSpc>
+                <a:spcPct val="110000"/>
+              </a:lnSpc>
+            </a:pPr>
+            <a:r>
+              <a:rPr sz="1000" b="0">
+                <a:solidFill>
+                  <a:srgbClr val="6B7586"/>
+                </a:solidFill>
+                <a:latin typeface="Segoe UI"/>
+              </a:rPr>
+              <a:t>6 / 7</a:t>
+            </a:r>
+          </a:p>
+        </p:txBody>
+      </p:sp>
+      <p:sp>
+        <p:nvSpPr>
+          <p:cNvPr id="7" name="TextBox 6"/>
+          <p:cNvSpPr txBox="1"/>
+          <p:nvPr/>
+        </p:nvSpPr>
+        <p:spPr>
+          <a:xfrm>
+            <a:off x="640080" y="1463040"/>
+            <a:ext cx="3566160" cy="274320"/>
+          </a:xfrm>
+          <a:prstGeom prst="rect">
+            <a:avLst/>
+          </a:prstGeom>
+          <a:noFill/>
+        </p:spPr>
+        <p:txBody>
+          <a:bodyPr wrap="square" anchor="t" lIns="0" rIns="0" tIns="0" bIns="0">
+            <a:spAutoFit/>
+          </a:bodyPr>
+          <a:lstStyle/>
+          <a:p>
+            <a:pPr algn="l">
+              <a:lnSpc>
+                <a:spcPct val="110000"/>
+              </a:lnSpc>
+            </a:pPr>
+            <a:r>
+              <a:rPr sz="1050" b="0">
+                <a:solidFill>
+                  <a:srgbClr val="1F3A5F"/>
+                </a:solidFill>
+                <a:latin typeface="Segoe UI Semibold"/>
+              </a:rPr>
+              <a:t>THE QUESTION</a:t>
+            </a:r>
+          </a:p>
+        </p:txBody>
+      </p:sp>
+      <p:sp>
+        <p:nvSpPr>
+          <p:cNvPr id="8" name="TextBox 7"/>
+          <p:cNvSpPr txBox="1"/>
+          <p:nvPr/>
+        </p:nvSpPr>
+        <p:spPr>
+          <a:xfrm>
+            <a:off x="640080" y="1709928"/>
+            <a:ext cx="3566160" cy="1280160"/>
+          </a:xfrm>
+          <a:prstGeom prst="rect">
+            <a:avLst/>
+          </a:prstGeom>
+          <a:noFill/>
+        </p:spPr>
+        <p:txBody>
+          <a:bodyPr wrap="square" anchor="t" lIns="0" rIns="0" tIns="0" bIns="0">
+            <a:spAutoFit/>
+          </a:bodyPr>
+          <a:lstStyle/>
+          <a:p>
+            <a:pPr algn="l">
+              <a:lnSpc>
+                <a:spcPct val="112000"/>
+              </a:lnSpc>
+            </a:pPr>
+            <a:r>
+              <a:rPr sz="1350" b="0">
+                <a:solidFill>
+                  <a:srgbClr val="1E2430"/>
+                </a:solidFill>
+                <a:latin typeface="Segoe UI"/>
+              </a:rPr>
+              <a:t>What happens when a signal is sampled slower than twice its highest frequency, in 1D and in images?</a:t>
+            </a:r>
+          </a:p>
+        </p:txBody>
+      </p:sp>
+      <p:sp>
+        <p:nvSpPr>
+          <p:cNvPr id="9" name="TextBox 8"/>
+          <p:cNvSpPr txBox="1"/>
+          <p:nvPr/>
+        </p:nvSpPr>
+        <p:spPr>
+          <a:xfrm>
+            <a:off x="640080" y="2715768"/>
+            <a:ext cx="3566160" cy="274320"/>
+          </a:xfrm>
+          <a:prstGeom prst="rect">
+            <a:avLst/>
+          </a:prstGeom>
+          <a:noFill/>
+        </p:spPr>
+        <p:txBody>
+          <a:bodyPr wrap="square" anchor="t" lIns="0" rIns="0" tIns="0" bIns="0">
+            <a:spAutoFit/>
+          </a:bodyPr>
+          <a:lstStyle/>
+          <a:p>
+            <a:pPr algn="l">
+              <a:lnSpc>
+                <a:spcPct val="110000"/>
+              </a:lnSpc>
+            </a:pPr>
+            <a:r>
+              <a:rPr sz="1050" b="0">
+                <a:solidFill>
+                  <a:srgbClr val="1F3A5F"/>
+                </a:solidFill>
+                <a:latin typeface="Segoe UI Semibold"/>
+              </a:rPr>
+              <a:t>WHAT I DID</a:t>
+            </a:r>
+          </a:p>
+        </p:txBody>
+      </p:sp>
+      <p:sp>
+        <p:nvSpPr>
+          <p:cNvPr id="10" name="TextBox 9"/>
+          <p:cNvSpPr txBox="1"/>
+          <p:nvPr/>
+        </p:nvSpPr>
+        <p:spPr>
+          <a:xfrm>
+            <a:off x="640080" y="2962656"/>
+            <a:ext cx="3566160" cy="1280160"/>
+          </a:xfrm>
+          <a:prstGeom prst="rect">
+            <a:avLst/>
+          </a:prstGeom>
+          <a:noFill/>
+        </p:spPr>
+        <p:txBody>
+          <a:bodyPr wrap="square" anchor="t" lIns="0" rIns="0" tIns="0" bIns="0">
+            <a:spAutoFit/>
+          </a:bodyPr>
+          <a:lstStyle/>
+          <a:p>
+            <a:pPr algn="l">
+              <a:lnSpc>
+                <a:spcPct val="112000"/>
+              </a:lnSpc>
+            </a:pPr>
+            <a:r>
+              <a:rPr sz="1350" b="0">
+                <a:solidFill>
+                  <a:srgbClr val="1E2430"/>
+                </a:solidFill>
+                <a:latin typeface="Segoe UI"/>
+              </a:rPr>
+              <a:t>Sampled 10 Hz and 90 Hz cosines at 100 Hz and 1 kHz in MATLAB, then shrank a test image with anti-aliasing off and on.</a:t>
+            </a:r>
+          </a:p>
+        </p:txBody>
+      </p:sp>
+      <p:sp>
+        <p:nvSpPr>
+          <p:cNvPr id="11" name="TextBox 10"/>
+          <p:cNvSpPr txBox="1"/>
+          <p:nvPr/>
+        </p:nvSpPr>
+        <p:spPr>
+          <a:xfrm>
+            <a:off x="640080" y="4206240"/>
+            <a:ext cx="3566160" cy="274320"/>
+          </a:xfrm>
+          <a:prstGeom prst="rect">
+            <a:avLst/>
+          </a:prstGeom>
+          <a:noFill/>
+        </p:spPr>
+        <p:txBody>
+          <a:bodyPr wrap="square" anchor="t" lIns="0" rIns="0" tIns="0" bIns="0">
+            <a:spAutoFit/>
+          </a:bodyPr>
+          <a:lstStyle/>
+          <a:p>
+            <a:pPr algn="l">
+              <a:lnSpc>
+                <a:spcPct val="110000"/>
+              </a:lnSpc>
+            </a:pPr>
+            <a:r>
+              <a:rPr sz="1050" b="0">
+                <a:solidFill>
+                  <a:srgbClr val="2A9D8F"/>
+                </a:solidFill>
+                <a:latin typeface="Segoe UI Semibold"/>
+              </a:rPr>
+              <a:t>CONCLUSION</a:t>
+            </a:r>
+          </a:p>
+        </p:txBody>
+      </p:sp>
+      <p:sp>
+        <p:nvSpPr>
+          <p:cNvPr id="12" name="TextBox 11"/>
+          <p:cNvSpPr txBox="1"/>
+          <p:nvPr/>
+        </p:nvSpPr>
+        <p:spPr>
+          <a:xfrm>
+            <a:off x="640080" y="4453128"/>
+            <a:ext cx="3566160" cy="1280160"/>
+          </a:xfrm>
+          <a:prstGeom prst="rect">
+            <a:avLst/>
+          </a:prstGeom>
+          <a:noFill/>
+        </p:spPr>
+        <p:txBody>
+          <a:bodyPr wrap="square" anchor="t" lIns="0" rIns="0" tIns="0" bIns="0">
+            <a:spAutoFit/>
+          </a:bodyPr>
+          <a:lstStyle/>
+          <a:p>
+            <a:pPr algn="l">
+              <a:lnSpc>
+                <a:spcPct val="112000"/>
+              </a:lnSpc>
+            </a:pPr>
+            <a:r>
+              <a:rPr sz="1350" b="0">
+                <a:solidFill>
+                  <a:srgbClr val="1E2430"/>
+                </a:solidFill>
+                <a:latin typeface="Segoe UI"/>
+              </a:rPr>
+              <a:t>At 100 Hz the two tones give identical samples (max difference 1.7×10⁻¹⁴). Shrinking an image is resampling too: fine stripes alias into moiré unless low-passed first.</a:t>
+            </a:r>
+          </a:p>
+        </p:txBody>
+      </p:sp>
+      <p:pic>
+        <p:nvPicPr>
+          <p:cNvPr id="13" name="Picture 12" descr="lab_alias.png"/>
+          <p:cNvPicPr>
+            <a:picLocks noChangeAspect="1"/>
+          </p:cNvPicPr>
+          <p:nvPr/>
+        </p:nvPicPr>
+        <p:blipFill>
+          <a:blip r:embed="rId2"/>
+          <a:stretch>
+            <a:fillRect/>
+          </a:stretch>
+        </p:blipFill>
+        <p:spPr>
+          <a:xfrm>
+            <a:off x="4526280" y="1371600"/>
+            <a:ext cx="7315200" cy="2451217"/>
+          </a:xfrm>
+          <a:prstGeom prst="rect">
+            <a:avLst/>
+          </a:prstGeom>
+        </p:spPr>
+      </p:pic>
+      <p:pic>
+        <p:nvPicPr>
+          <p:cNvPr id="14" name="Picture 13" descr="lab_alias_img.png"/>
+          <p:cNvPicPr>
+            <a:picLocks noChangeAspect="1"/>
+          </p:cNvPicPr>
+          <p:nvPr/>
+        </p:nvPicPr>
+        <p:blipFill>
+          <a:blip r:embed="rId3"/>
+          <a:stretch>
+            <a:fillRect/>
+          </a:stretch>
+        </p:blipFill>
+        <p:spPr>
+          <a:xfrm>
+            <a:off x="4526280" y="3977639"/>
+            <a:ext cx="4324786" cy="2331720"/>
+          </a:xfrm>
+          <a:prstGeom prst="rect">
+            <a:avLst/>
+          </a:prstGeom>
+        </p:spPr>
+      </p:pic>
+      <p:sp>
+        <p:nvSpPr>
+          <p:cNvPr id="15" name="TextBox 14"/>
+          <p:cNvSpPr txBox="1"/>
+          <p:nvPr/>
+        </p:nvSpPr>
+        <p:spPr>
+          <a:xfrm>
+            <a:off x="8961120" y="4206240"/>
+            <a:ext cx="2926080" cy="2011680"/>
+          </a:xfrm>
+          <a:prstGeom prst="rect">
+            <a:avLst/>
+          </a:prstGeom>
+          <a:noFill/>
+        </p:spPr>
+        <p:txBody>
+          <a:bodyPr wrap="square" anchor="t" lIns="0" rIns="0" tIns="0" bIns="0">
+            <a:spAutoFit/>
+          </a:bodyPr>
+          <a:lstStyle/>
+          <a:p>
+            <a:pPr algn="l">
+              <a:lnSpc>
+                <a:spcPct val="110000"/>
+              </a:lnSpc>
+            </a:pPr>
+            <a:r>
+              <a:rPr sz="1250" b="1">
+                <a:solidFill>
+                  <a:srgbClr val="1E2430"/>
+                </a:solidFill>
+                <a:latin typeface="Segoe UI"/>
+              </a:rPr>
+              <a:t>Left:</a:t>
+            </a:r>
+            <a:r>
+              <a:rPr sz="1250" b="0">
+                <a:solidFill>
+                  <a:srgbClr val="1E2430"/>
+                </a:solidFill>
+                <a:latin typeface="Segoe UI"/>
+              </a:rPr>
+              <a:t> stripes on the clothing turn into false wavy bands.</a:t>
+            </a:r>
+          </a:p>
+          <a:p>
+            <a:pPr algn="l">
+              <a:lnSpc>
+                <a:spcPct val="110000"/>
+              </a:lnSpc>
+              <a:spcBef>
+                <a:spcPts val="600"/>
+              </a:spcBef>
+            </a:pPr>
+            <a:r>
+              <a:rPr sz="1250" b="1">
+                <a:solidFill>
+                  <a:srgbClr val="1E2430"/>
+                </a:solidFill>
+                <a:latin typeface="Segoe UI"/>
+              </a:rPr>
+              <a:t>Right:</a:t>
+            </a:r>
+            <a:r>
+              <a:rPr sz="1250" b="0">
+                <a:solidFill>
+                  <a:srgbClr val="1E2430"/>
+                </a:solidFill>
+                <a:latin typeface="Segoe UI"/>
+              </a:rPr>
+              <a:t> filtered first, they fade to grey instead. Cost: a little blur.</a:t>
+            </a:r>
+          </a:p>
+        </p:txBody>
+      </p:sp>
+    </p:spTree>
+  </p:cSld>
+  <p:clrMapOvr>
+    <a:masterClrMapping/>
+  </p:clrMapOvr>
+</p:sld>
+</file>
+
+<file path=ppt/slides/slide7.xml><?xml version="1.0" encoding="utf-8"?>
 <p:sld xmlns:a="http://schemas.openxmlformats.org/drawingml/2006/main" xmlns:p="http://schemas.openxmlformats.org/presentationml/2006/main" xmlns:r="http://schemas.openxmlformats.org/officeDocument/2006/relationships">
   <p:cSld>
     <p:spTree>

</xml_diff>